<commit_message>
docs/pitch: match Jacky's canvas wording - no Palantir or OODA framing
Cover tagline dropped; 'gotham' slide is now 'How the sensors come together'
with the 'Nine systems, nine logins' quote; the loop slide is See / Fuse /
Decide / Act. Speaker notes and the .pptx export follow the same wording.

Co-Authored-By: Claude Opus 5.5 <noreply@anthropic.com>
</commit_message>
<xml_diff>
--- a/docs/pitch/keynote/Lauds-keynote.pptx
+++ b/docs/pitch/keynote/Lauds-keynote.pptx
@@ -1116,7 +1116,7 @@
           <a:p/>
           <a:p>
             <a:r>
-              <a:t>Gotham's users think in OODA loops: observe, orient, decide, act. Lauds runs that loop every morning. Observe: read every sensor. Orient: fuse it into one model, so one quiz on two platforms is one item. Decide: rank by urgency, weighted by what matters to you. Act: one click opens it where it lives, or checks it off. Most student tools stop at observe. Lauds closes the loop.</a:t>
+              <a:t>And it runs as a tight loop, every morning. See it: read every sensor. Fuse it: one model, so one quiz on two platforms is one item. Decide: rank by urgency, weighted by what matters to you. Act: one click opens it where it lives, or checks it off. Most student tools stop at reading. Lauds closes the loop, before you open any other tab.</a:t>
             </a:r>
           </a:p>
           <a:p/>
@@ -1127,7 +1127,7 @@
           </a:p>
           <a:p>
             <a:r>
-              <a:t>Background: OODA is John Boyd's decision loop. Orient is highlighted because fusion is the product.</a:t>
+              <a:t>Background: Fuse is highlighted because fusion is the product.</a:t>
             </a:r>
           </a:p>
         </p:txBody>
@@ -1377,7 +1377,7 @@
           <a:p/>
           <a:p>
             <a:r>
-              <a:t>If that sounds familiar, it's the idea behind Palantir Gotham, which fuses many narrow intelligence feeds into one operating picture. We built Gotham for students. The sensors are across the top. Each one gets a small adapter that translates it into one shared model: courses, items and textbooks. Fusion only happens on that model. That's how CPSC underscore V 110 in Canvas and CPSC 110 in Piazza become one course. That's the product: the join, not any single connector.</a:t>
+              <a:t>Here's how the sensors come together. Across the top are the systems Stu already uses: nine systems, nine logins, nine separate habits. Each one gets a small adapter that translates it into one shared model: courses, items and textbooks. Fusion only happens on that model. That's how CPSC underscore V 110 in Canvas and CPSC 110 in Piazza become one course. We fuse them into one morning check. The fusion layer is the product, not any single connector.</a:t>
             </a:r>
           </a:p>
           <a:p/>
@@ -1388,7 +1388,7 @@
           </a:p>
           <a:p>
             <a:r>
-              <a:t>Background: Gotham's word for the shared vocabulary is the ontology. If asked: Course, Item (anything due or announced), Textbook.</a:t>
+              <a:t>Background: The ontology is the one shared vocabulary every source is translated into. If asked: Course, Item (anything due or announced), Textbook.</a:t>
             </a:r>
           </a:p>
         </p:txBody>
@@ -4956,45 +4956,6 @@
           </a:p>
         </p:txBody>
       </p:sp>
-      <p:sp>
-        <p:nvSpPr>
-          <p:cNvPr id="5" name="TextBox 4"/>
-          <p:cNvSpPr txBox="1"/>
-          <p:nvPr/>
-        </p:nvSpPr>
-        <p:spPr>
-          <a:xfrm>
-            <a:off x="731520" y="5989320"/>
-            <a:ext cx="10698480" cy="365760"/>
-          </a:xfrm>
-          <a:prstGeom prst="rect">
-            <a:avLst/>
-          </a:prstGeom>
-          <a:noFill/>
-        </p:spPr>
-        <p:txBody>
-          <a:bodyPr wrap="square" anchor="t" lIns="0" rIns="0" tIns="0" bIns="0">
-            <a:spAutoFit/>
-          </a:bodyPr>
-          <a:lstStyle/>
-          <a:p>
-            <a:pPr algn="l">
-              <a:spcAft>
-                <a:spcPts val="0"/>
-              </a:spcAft>
-            </a:pPr>
-            <a:r>
-              <a:rPr sz="1600" b="1" i="0">
-                <a:solidFill>
-                  <a:srgbClr val="F4C3B3"/>
-                </a:solidFill>
-                <a:latin typeface="Arial"/>
-              </a:rPr>
-              <a:t>Palantir Gotham for students</a:t>
-            </a:r>
-          </a:p>
-        </p:txBody>
-      </p:sp>
     </p:spTree>
   </p:cSld>
   <p:clrMapOvr>
@@ -6958,7 +6919,7 @@
                 </a:solidFill>
                 <a:latin typeface="Arial"/>
               </a:rPr>
-              <a:t>Why 'Gotham for students'?</a:t>
+              <a:t>Why fusion, not another dashboard?</a:t>
             </a:r>
           </a:p>
           <a:p>
@@ -6974,7 +6935,7 @@
                 </a:solidFill>
                 <a:latin typeface="Arial"/>
               </a:rPr>
-              <a:t>Gotham fuses narrow intelligence feeds into one operating picture. Each student system is a narrow feed.</a:t>
+              <a:t>Other dashboards show one platform. Lauds joins nine, so duplicates merge and one ranked list covers everything.</a:t>
             </a:r>
           </a:p>
           <a:p>
@@ -7137,7 +7098,7 @@
                 <a:gridCol w="5349240"/>
                 <a:gridCol w="5349240"/>
               </a:tblGrid>
-              <a:tr h="600891">
+              <a:tr h="525780">
                 <a:tc>
                   <a:txBody>
                     <a:bodyPr/>
@@ -7193,7 +7154,7 @@
                   </a:tcPr>
                 </a:tc>
               </a:tr>
-              <a:tr h="600891">
+              <a:tr h="525780">
                 <a:tc>
                   <a:txBody>
                     <a:bodyPr/>
@@ -7249,7 +7210,7 @@
                   </a:tcPr>
                 </a:tc>
               </a:tr>
-              <a:tr h="600891">
+              <a:tr h="525780">
                 <a:tc>
                   <a:txBody>
                     <a:bodyPr/>
@@ -7305,7 +7266,7 @@
                   </a:tcPr>
                 </a:tc>
               </a:tr>
-              <a:tr h="600891">
+              <a:tr h="525780">
                 <a:tc>
                   <a:txBody>
                     <a:bodyPr/>
@@ -7361,7 +7322,7 @@
                   </a:tcPr>
                 </a:tc>
               </a:tr>
-              <a:tr h="600891">
+              <a:tr h="525780">
                 <a:tc>
                   <a:txBody>
                     <a:bodyPr/>
@@ -7417,7 +7378,7 @@
                   </a:tcPr>
                 </a:tc>
               </a:tr>
-              <a:tr h="600891">
+              <a:tr h="525780">
                 <a:tc>
                   <a:txBody>
                     <a:bodyPr/>
@@ -7473,7 +7434,7 @@
                   </a:tcPr>
                 </a:tc>
               </a:tr>
-              <a:tr h="600894">
+              <a:tr h="525780">
                 <a:tc>
                   <a:txBody>
                     <a:bodyPr/>
@@ -7529,6 +7490,62 @@
                   </a:tcPr>
                 </a:tc>
               </a:tr>
+              <a:tr h="525780">
+                <a:tc>
+                  <a:txBody>
+                    <a:bodyPr/>
+                    <a:lstStyle/>
+                    <a:p>
+                      <a:pPr algn="l">
+                        <a:spcAft>
+                          <a:spcPts val="0"/>
+                        </a:spcAft>
+                      </a:pPr>
+                      <a:r>
+                        <a:rPr sz="1500" b="0" i="0">
+                          <a:solidFill>
+                            <a:srgbClr val="5F6B65"/>
+                          </a:solidFill>
+                          <a:latin typeface="Arial"/>
+                        </a:rPr>
+                        <a:t>Comparisons to Palantir or military language</a:t>
+                      </a:r>
+                    </a:p>
+                  </a:txBody>
+                  <a:tcPr marL="137160" marR="137160">
+                    <a:solidFill>
+                      <a:srgbClr val="FFFFFF"/>
+                    </a:solidFill>
+                  </a:tcPr>
+                </a:tc>
+                <a:tc>
+                  <a:txBody>
+                    <a:bodyPr/>
+                    <a:lstStyle/>
+                    <a:p>
+                      <a:pPr algn="l">
+                        <a:spcAft>
+                          <a:spcPts val="0"/>
+                        </a:spcAft>
+                      </a:pPr>
+                      <a:r>
+                        <a:rPr sz="1500" b="1" i="0">
+                          <a:solidFill>
+                            <a:srgbClr val="17211B"/>
+                          </a:solidFill>
+                          <a:latin typeface="Arial"/>
+                        </a:rPr>
+                        <a:t>"Many narrow sensors, one fused picture."</a:t>
+                      </a:r>
+                    </a:p>
+                  </a:txBody>
+                  <a:tcPr marL="137160" marR="137160">
+                    <a:solidFill>
+                      <a:srgbClr val="FFFFFF"/>
+                    </a:solidFill>
+                  </a:tcPr>
+                </a:tc>
+              </a:tr>
             </a:tbl>
           </a:graphicData>
         </a:graphic>
@@ -7632,7 +7649,7 @@
                 </a:solidFill>
                 <a:latin typeface="Arial"/>
               </a:rPr>
-              <a:t>An OODA loop for every student's morning</a:t>
+              <a:t>A tight loop for every student's morning</a:t>
             </a:r>
           </a:p>
         </p:txBody>
@@ -7671,7 +7688,7 @@
                 </a:solidFill>
                 <a:latin typeface="Arial"/>
               </a:rPr>
-              <a:t>Observe, orient, decide, act: the decision loop from military strategy, run on a student's week.</a:t>
+              <a:t>See it, fuse it, rank it, act on it: a tight four-step loop, run on a student's week.</a:t>
             </a:r>
           </a:p>
         </p:txBody>
@@ -7732,7 +7749,7 @@
                 </a:solidFill>
                 <a:latin typeface="Arial"/>
               </a:rPr>
-              <a:t>OBSERVE</a:t>
+              <a:t>SEE</a:t>
             </a:r>
           </a:p>
           <a:p>
@@ -7823,7 +7840,7 @@
                 </a:solidFill>
                 <a:latin typeface="Arial"/>
               </a:rPr>
-              <a:t>ORIENT</a:t>
+              <a:t>FUSE</a:t>
             </a:r>
           </a:p>
           <a:p>
@@ -8276,7 +8293,7 @@
                 </a:solidFill>
                 <a:latin typeface="Arial"/>
               </a:rPr>
-              <a:t>Most student tools stop at Observe.</a:t>
+              <a:t>Most student tools stop at reading.</a:t>
             </a:r>
           </a:p>
           <a:p>
@@ -8769,7 +8786,7 @@
                 </a:solidFill>
                 <a:latin typeface="Arial"/>
               </a:rPr>
-              <a:t>SENSOR FUSION</a:t>
+              <a:t>WHY?</a:t>
             </a:r>
           </a:p>
         </p:txBody>
@@ -9203,8 +9220,8 @@
         </p:nvSpPr>
         <p:spPr>
           <a:xfrm>
-            <a:off x="731520" y="411480"/>
-            <a:ext cx="10698480" cy="640080"/>
+            <a:off x="731520" y="320040"/>
+            <a:ext cx="10698480" cy="320040"/>
           </a:xfrm>
           <a:prstGeom prst="rect">
             <a:avLst/>
@@ -9223,13 +9240,13 @@
               </a:spcAft>
             </a:pPr>
             <a:r>
-              <a:rPr sz="2800" b="1" i="0">
-                <a:solidFill>
-                  <a:srgbClr val="17211B"/>
-                </a:solidFill>
-                <a:latin typeface="Arial"/>
-              </a:rPr>
-              <a:t>Gotham for students: many narrow sensors, one picture</a:t>
+              <a:rPr sz="1300" b="1" i="0" spc="300">
+                <a:solidFill>
+                  <a:srgbClr val="B84028"/>
+                </a:solidFill>
+                <a:latin typeface="Arial"/>
+              </a:rPr>
+              <a:t>HOW THE SENSORS COME TOGETHER</a:t>
             </a:r>
           </a:p>
         </p:txBody>
@@ -9242,8 +9259,8 @@
         </p:nvSpPr>
         <p:spPr>
           <a:xfrm>
-            <a:off x="731520" y="1188720"/>
-            <a:ext cx="6766560" cy="274320"/>
+            <a:off x="731520" y="594360"/>
+            <a:ext cx="10698480" cy="548640"/>
           </a:xfrm>
           <a:prstGeom prst="rect">
             <a:avLst/>
@@ -9262,6 +9279,45 @@
               </a:spcAft>
             </a:pPr>
             <a:r>
+              <a:rPr sz="2800" b="1" i="0">
+                <a:solidFill>
+                  <a:srgbClr val="17211B"/>
+                </a:solidFill>
+                <a:latin typeface="Arial"/>
+              </a:rPr>
+              <a:t>Many narrow sensors, one fused picture.</a:t>
+            </a:r>
+          </a:p>
+        </p:txBody>
+      </p:sp>
+      <p:sp>
+        <p:nvSpPr>
+          <p:cNvPr id="4" name="TextBox 3"/>
+          <p:cNvSpPr txBox="1"/>
+          <p:nvPr/>
+        </p:nvSpPr>
+        <p:spPr>
+          <a:xfrm>
+            <a:off x="731520" y="1188720"/>
+            <a:ext cx="6766560" cy="274320"/>
+          </a:xfrm>
+          <a:prstGeom prst="rect">
+            <a:avLst/>
+          </a:prstGeom>
+          <a:noFill/>
+        </p:spPr>
+        <p:txBody>
+          <a:bodyPr wrap="square" anchor="t" lIns="0" rIns="0" tIns="0" bIns="0">
+            <a:spAutoFit/>
+          </a:bodyPr>
+          <a:lstStyle/>
+          <a:p>
+            <a:pPr algn="l">
+              <a:spcAft>
+                <a:spcPts val="0"/>
+              </a:spcAft>
+            </a:pPr>
+            <a:r>
               <a:rPr sz="1100" b="1" i="0" spc="150">
                 <a:solidFill>
                   <a:srgbClr val="5F6B65"/>
@@ -9275,7 +9331,7 @@
       </p:sp>
       <p:sp>
         <p:nvSpPr>
-          <p:cNvPr id="4" name="Rounded Rectangle 3"/>
+          <p:cNvPr id="5" name="Rounded Rectangle 4"/>
           <p:cNvSpPr/>
           <p:nvPr/>
         </p:nvSpPr>
@@ -9336,7 +9392,7 @@
       </p:sp>
       <p:sp>
         <p:nvSpPr>
-          <p:cNvPr id="5" name="Rounded Rectangle 4"/>
+          <p:cNvPr id="6" name="Rounded Rectangle 5"/>
           <p:cNvSpPr/>
           <p:nvPr/>
         </p:nvSpPr>
@@ -9397,7 +9453,7 @@
       </p:sp>
       <p:sp>
         <p:nvSpPr>
-          <p:cNvPr id="6" name="Rounded Rectangle 5"/>
+          <p:cNvPr id="7" name="Rounded Rectangle 6"/>
           <p:cNvSpPr/>
           <p:nvPr/>
         </p:nvSpPr>
@@ -9458,7 +9514,7 @@
       </p:sp>
       <p:sp>
         <p:nvSpPr>
-          <p:cNvPr id="7" name="Rounded Rectangle 6"/>
+          <p:cNvPr id="8" name="Rounded Rectangle 7"/>
           <p:cNvSpPr/>
           <p:nvPr/>
         </p:nvSpPr>
@@ -9519,7 +9575,7 @@
       </p:sp>
       <p:sp>
         <p:nvSpPr>
-          <p:cNvPr id="8" name="Rounded Rectangle 7"/>
+          <p:cNvPr id="9" name="Rounded Rectangle 8"/>
           <p:cNvSpPr/>
           <p:nvPr/>
         </p:nvSpPr>
@@ -9580,7 +9636,7 @@
       </p:sp>
       <p:sp>
         <p:nvSpPr>
-          <p:cNvPr id="9" name="Rounded Rectangle 8"/>
+          <p:cNvPr id="10" name="Rounded Rectangle 9"/>
           <p:cNvSpPr/>
           <p:nvPr/>
         </p:nvSpPr>
@@ -9641,7 +9697,7 @@
       </p:sp>
       <p:sp>
         <p:nvSpPr>
-          <p:cNvPr id="10" name="Down Arrow 9"/>
+          <p:cNvPr id="11" name="Down Arrow 10"/>
           <p:cNvSpPr/>
           <p:nvPr/>
         </p:nvSpPr>
@@ -9685,7 +9741,7 @@
       </p:sp>
       <p:sp>
         <p:nvSpPr>
-          <p:cNvPr id="11" name="Rounded Rectangle 10"/>
+          <p:cNvPr id="12" name="Rounded Rectangle 11"/>
           <p:cNvSpPr/>
           <p:nvPr/>
         </p:nvSpPr>
@@ -9762,7 +9818,7 @@
       </p:sp>
       <p:sp>
         <p:nvSpPr>
-          <p:cNvPr id="12" name="Down Arrow 11"/>
+          <p:cNvPr id="13" name="Down Arrow 12"/>
           <p:cNvSpPr/>
           <p:nvPr/>
         </p:nvSpPr>
@@ -9806,7 +9862,7 @@
       </p:sp>
       <p:sp>
         <p:nvSpPr>
-          <p:cNvPr id="13" name="Rounded Rectangle 12"/>
+          <p:cNvPr id="14" name="Rounded Rectangle 13"/>
           <p:cNvSpPr/>
           <p:nvPr/>
         </p:nvSpPr>
@@ -9883,7 +9939,7 @@
       </p:sp>
       <p:sp>
         <p:nvSpPr>
-          <p:cNvPr id="14" name="Down Arrow 13"/>
+          <p:cNvPr id="15" name="Down Arrow 14"/>
           <p:cNvSpPr/>
           <p:nvPr/>
         </p:nvSpPr>
@@ -9927,7 +9983,7 @@
       </p:sp>
       <p:sp>
         <p:nvSpPr>
-          <p:cNvPr id="15" name="Rounded Rectangle 14"/>
+          <p:cNvPr id="16" name="Rounded Rectangle 15"/>
           <p:cNvSpPr/>
           <p:nvPr/>
         </p:nvSpPr>
@@ -10004,7 +10060,7 @@
       </p:sp>
       <p:sp>
         <p:nvSpPr>
-          <p:cNvPr id="16" name="Down Arrow 15"/>
+          <p:cNvPr id="17" name="Down Arrow 16"/>
           <p:cNvSpPr/>
           <p:nvPr/>
         </p:nvSpPr>
@@ -10048,7 +10104,7 @@
       </p:sp>
       <p:sp>
         <p:nvSpPr>
-          <p:cNvPr id="17" name="Rounded Rectangle 16"/>
+          <p:cNvPr id="18" name="Rounded Rectangle 17"/>
           <p:cNvSpPr/>
           <p:nvPr/>
         </p:nvSpPr>
@@ -10123,7 +10179,7 @@
       </p:sp>
       <p:sp>
         <p:nvSpPr>
-          <p:cNvPr id="18" name="Rounded Rectangle 17"/>
+          <p:cNvPr id="19" name="Rounded Rectangle 18"/>
           <p:cNvSpPr/>
           <p:nvPr/>
         </p:nvSpPr>
@@ -10175,7 +10231,7 @@
                 </a:solidFill>
                 <a:latin typeface="Arial"/>
               </a:rPr>
-              <a:t>THE GOTHAM LINE</a:t>
+              <a:t>THE IDEA</a:t>
             </a:r>
           </a:p>
           <a:p>
@@ -10191,7 +10247,7 @@
                 </a:solidFill>
                 <a:latin typeface="Arial"/>
               </a:rPr>
-              <a:t>"Gotham fuses intelligence feeds into one operating picture. We fuse a student's nine systems into one morning check."</a:t>
+              <a:t>"Nine systems, nine logins, nine separate habits. We fuse them into one morning check."</a:t>
             </a:r>
           </a:p>
           <a:p>

</xml_diff>